<commit_message>
feat(etiquetas): vista previa de etiqueta (LibreOffice) + fuentes Kollektif/Now instaladas e incrustadas en plantillas
Co-Authored-By: Claude Opus 4.8 <noreply@anthropic.com>
</commit_message>
<xml_diff>
--- a/addons/amunet_label/static/templates/PLANTILLA_A.pptx
+++ b/addons/amunet_label/static/templates/PLANTILLA_A.pptx
@@ -112,6 +112,20 @@
       <p15:sldGuideLst xmlns:p15="http://schemas.microsoft.com/office/powerpoint/2012/main"/>
     </p:ext>
   </p:extLst>
+  <p:embeddedFontLst>
+    <p:embeddedFont>
+      <p:font typeface="Kollektif"/>
+      <p:regular r:id="rId8"/>
+      <p:bold r:id="rId9"/>
+      <p:italic r:id="rId10"/>
+      <p:boldItalic r:id="rId11"/>
+    </p:embeddedFont>
+    <p:embeddedFont>
+      <p:font typeface="Now"/>
+      <p:regular r:id="rId12"/>
+      <p:bold r:id="rId13"/>
+    </p:embeddedFont>
+  </p:embeddedFontLst>
 </p:presentation>
 </file>
 

</xml_diff>